<commit_message>
feat: Manual de identidad corregido con logo correcto, link de figma correcto
</commit_message>
<xml_diff>
--- a/public/Manual_Identidad_TechCupV2.pptx
+++ b/public/Manual_Identidad_TechCupV2.pptx
@@ -1940,10 +1940,10 @@
       </p:sp>
       <p:pic>
         <p:nvPicPr>
-          <p:cNvPr id="16" name="Imagen 15">
+          <p:cNvPr id="15" name="Imagen 14">
             <a:extLst>
               <a:ext uri="{FF2B5EF4-FFF2-40B4-BE49-F238E27FC236}">
-                <a16:creationId xmlns:a16="http://schemas.microsoft.com/office/drawing/2014/main" id="{6D1C5357-1DEB-9C0E-034B-7C7C2C2E9CB4}"/>
+                <a16:creationId xmlns:a16="http://schemas.microsoft.com/office/drawing/2014/main" id="{04738614-1355-E8D1-B6D5-A2C748972239}"/>
               </a:ext>
             </a:extLst>
           </p:cNvPr>
@@ -1953,43 +1953,156 @@
           <p:nvPr/>
         </p:nvPicPr>
         <p:blipFill>
-          <a:blip r:embed="rId3"/>
+          <a:blip r:embed="rId3">
+            <a:extLst>
+              <a:ext uri="{BEBA8EAE-BF5A-486C-A8C5-ECC9F3942E4B}">
+                <a14:imgProps xmlns:a14="http://schemas.microsoft.com/office/drawing/2010/main">
+                  <a14:imgLayer r:embed="rId4">
+                    <a14:imgEffect>
+                      <a14:backgroundRemoval t="6836" b="89844" l="6641" r="91797">
+                        <a14:foregroundMark x1="26172" y1="10059" x2="56348" y2="6934"/>
+                        <a14:foregroundMark x1="56348" y1="6934" x2="66699" y2="8398"/>
+                        <a14:foregroundMark x1="66699" y1="8398" x2="42090" y2="6934"/>
+                        <a14:foregroundMark x1="42090" y1="6934" x2="29492" y2="8691"/>
+                        <a14:foregroundMark x1="29492" y1="8691" x2="38965" y2="7129"/>
+                        <a14:foregroundMark x1="38965" y1="7129" x2="61914" y2="8594"/>
+                        <a14:foregroundMark x1="61914" y1="8594" x2="33301" y2="9961"/>
+                        <a14:foregroundMark x1="33301" y1="9961" x2="45801" y2="9766"/>
+                        <a14:foregroundMark x1="45801" y1="9766" x2="54395" y2="10059"/>
+                        <a14:foregroundMark x1="54395" y1="10059" x2="65723" y2="9766"/>
+                        <a14:foregroundMark x1="65723" y1="9766" x2="40723" y2="9766"/>
+                        <a14:foregroundMark x1="40723" y1="9766" x2="29980" y2="24707"/>
+                        <a14:foregroundMark x1="38281" y1="8301" x2="48730" y2="5859"/>
+                        <a14:foregroundMark x1="48730" y1="5859" x2="59961" y2="7422"/>
+                        <a14:foregroundMark x1="59961" y1="7422" x2="40625" y2="6836"/>
+                        <a14:foregroundMark x1="12598" y1="39355" x2="9863" y2="49512"/>
+                        <a14:foregroundMark x1="9863" y1="49512" x2="19141" y2="48047"/>
+                        <a14:foregroundMark x1="19141" y1="48047" x2="10352" y2="51172"/>
+                        <a14:foregroundMark x1="10352" y1="51172" x2="21777" y2="49414"/>
+                        <a14:foregroundMark x1="21777" y1="49414" x2="22266" y2="48340"/>
+                        <a14:foregroundMark x1="16113" y1="43457" x2="6836" y2="40527"/>
+                        <a14:foregroundMark x1="6836" y1="40527" x2="11523" y2="40039"/>
+                        <a14:foregroundMark x1="8984" y1="40332" x2="9375" y2="39941"/>
+                        <a14:foregroundMark x1="9375" y1="38867" x2="6641" y2="37988"/>
+                        <a14:foregroundMark x1="88965" y1="37793" x2="90723" y2="46387"/>
+                        <a14:foregroundMark x1="90723" y1="46387" x2="83105" y2="50781"/>
+                        <a14:foregroundMark x1="83105" y1="50781" x2="78613" y2="48340"/>
+                        <a14:foregroundMark x1="90039" y1="42383" x2="89746" y2="38672"/>
+                        <a14:foregroundMark x1="89453" y1="40820" x2="91797" y2="39258"/>
+                        <a14:foregroundMark x1="9375" y1="51172" x2="9473" y2="51855"/>
+                        <a14:foregroundMark x1="52832" y1="52930" x2="41211" y2="53809"/>
+                        <a14:foregroundMark x1="41211" y1="53809" x2="39648" y2="65137"/>
+                        <a14:foregroundMark x1="39648" y1="65137" x2="47168" y2="73633"/>
+                        <a14:foregroundMark x1="47168" y1="73633" x2="56641" y2="73730"/>
+                        <a14:foregroundMark x1="56641" y1="73730" x2="58105" y2="63965"/>
+                        <a14:foregroundMark x1="58105" y1="63965" x2="43945" y2="68457"/>
+                        <a14:foregroundMark x1="43945" y1="68457" x2="54883" y2="64844"/>
+                        <a14:foregroundMark x1="54883" y1="64844" x2="45117" y2="70898"/>
+                        <a14:foregroundMark x1="45117" y1="70898" x2="51953" y2="79785"/>
+                        <a14:foregroundMark x1="51953" y1="79785" x2="61230" y2="74414"/>
+                        <a14:foregroundMark x1="61230" y1="74414" x2="52637" y2="78906"/>
+                        <a14:foregroundMark x1="52637" y1="78906" x2="40332" y2="66895"/>
+                        <a14:foregroundMark x1="40332" y1="66895" x2="50488" y2="67969"/>
+                        <a14:foregroundMark x1="50488" y1="67969" x2="45410" y2="75391"/>
+                        <a14:foregroundMark x1="45410" y1="75391" x2="46973" y2="74121"/>
+                        <a14:foregroundMark x1="58203" y1="58691" x2="57031" y2="60059"/>
+                        <a14:foregroundMark x1="60254" y1="59082" x2="58789" y2="59863"/>
+                        <a14:foregroundMark x1="62207" y1="62891" x2="60059" y2="63281"/>
+                        <a14:foregroundMark x1="23291" y1="82617" x2="23730" y2="83496"/>
+                        <a14:foregroundMark x1="23047" y1="82129" x2="23291" y2="82617"/>
+                        <a14:foregroundMark x1="25391" y1="83496" x2="25488" y2="82813"/>
+                        <a14:foregroundMark x1="28418" y1="84006" x2="28418" y2="84570"/>
+                        <a14:foregroundMark x1="33301" y1="84961" x2="32617" y2="84863"/>
+                        <a14:foregroundMark x1="35742" y1="85547" x2="35742" y2="85547"/>
+                        <a14:foregroundMark x1="39258" y1="85156" x2="39258" y2="85156"/>
+                        <a14:foregroundMark x1="43359" y1="85547" x2="43359" y2="85547"/>
+                        <a14:foregroundMark x1="38379" y1="85742" x2="38379" y2="85742"/>
+                        <a14:foregroundMark x1="46973" y1="86035" x2="46973" y2="86035"/>
+                        <a14:foregroundMark x1="51172" y1="86035" x2="51172" y2="86035"/>
+                        <a14:foregroundMark x1="52930" y1="85156" x2="52930" y2="85156"/>
+                        <a14:foregroundMark x1="56543" y1="85156" x2="56543" y2="85156"/>
+                        <a14:foregroundMark x1="61328" y1="83594" x2="61328" y2="83594"/>
+                        <a14:foregroundMark x1="60449" y1="85059" x2="60449" y2="85059"/>
+                        <a14:foregroundMark x1="63184" y1="84375" x2="63184" y2="84375"/>
+                        <a14:foregroundMark x1="67578" y1="84082" x2="67578" y2="84082"/>
+                        <a14:foregroundMark x1="69043" y1="83203" x2="69043" y2="83203"/>
+                        <a14:foregroundMark x1="72070" y1="83008" x2="72070" y2="83008"/>
+                        <a14:foregroundMark x1="75195" y1="82031" x2="75195" y2="82031"/>
+                        <a14:foregroundMark x1="79297" y1="81348" x2="79297" y2="81348"/>
+                        <a14:foregroundMark x1="20020" y1="80664" x2="20020" y2="80664"/>
+                        <a14:foregroundMark x1="19824" y1="81543" x2="19824" y2="81543"/>
+                        <a14:foregroundMark x1="19434" y1="83008" x2="19434" y2="83008"/>
+                        <a14:foregroundMark x1="21289" y1="81543" x2="21359" y2="81264"/>
+                        <a14:foregroundMark x1="21070" y1="82422" x2="21289" y2="81543"/>
+                        <a14:foregroundMark x1="20801" y1="83496" x2="20972" y2="82813"/>
+                        <a14:foregroundMark x1="20898" y1="81152" x2="20898" y2="80664"/>
+                        <a14:foregroundMark x1="79395" y1="81641" x2="79395" y2="81641"/>
+                        <a14:foregroundMark x1="79004" y1="80859" x2="79004" y2="80859"/>
+                        <a14:foregroundMark x1="19434" y1="82520" x2="19434" y2="82520"/>
+                        <a14:foregroundMark x1="22363" y1="83691" x2="22363" y2="83691"/>
+                        <a14:foregroundMark x1="20117" y1="83203" x2="20117" y2="83203"/>
+                        <a14:foregroundMark x1="20117" y1="83008" x2="20117" y2="83008"/>
+                        <a14:foregroundMark x1="19922" y1="82910" x2="19922" y2="82910"/>
+                        <a14:foregroundMark x1="19629" y1="82813" x2="19629" y2="82813"/>
+                        <a14:foregroundMark x1="20020" y1="82813" x2="20020" y2="82813"/>
+                        <a14:foregroundMark x1="19922" y1="82910" x2="19922" y2="82910"/>
+                        <a14:foregroundMark x1="19531" y1="82813" x2="20020" y2="82813"/>
+                        <a14:foregroundMark x1="38770" y1="85645" x2="38770" y2="85645"/>
+                        <a14:foregroundMark x1="38477" y1="86035" x2="38770" y2="85449"/>
+                        <a14:backgroundMark x1="44238" y1="86035" x2="44238" y2="86328"/>
+                        <a14:backgroundMark x1="38965" y1="93945" x2="38965" y2="93945"/>
+                        <a14:backgroundMark x1="28320" y1="83203" x2="28320" y2="83203"/>
+                        <a14:backgroundMark x1="28516" y1="82910" x2="27930" y2="83691"/>
+                        <a14:backgroundMark x1="72559" y1="83203" x2="72559" y2="83203"/>
+                        <a14:backgroundMark x1="76367" y1="82910" x2="76367" y2="82910"/>
+                        <a14:backgroundMark x1="79297" y1="81445" x2="79297" y2="81445"/>
+                        <a14:backgroundMark x1="22266" y1="80176" x2="20605" y2="79492"/>
+                        <a14:backgroundMark x1="20898" y1="81152" x2="20898" y2="81152"/>
+                        <a14:backgroundMark x1="20703" y1="82813" x2="20703" y2="82813"/>
+                        <a14:backgroundMark x1="20313" y1="82422" x2="20313" y2="82422"/>
+                        <a14:backgroundMark x1="21191" y1="82617" x2="21191" y2="82617"/>
+                        <a14:backgroundMark x1="20703" y1="81152" x2="20703" y2="81152"/>
+                        <a14:backgroundMark x1="21191" y1="81152" x2="21484" y2="81348"/>
+                        <a14:backgroundMark x1="21289" y1="82813" x2="21094" y2="82813"/>
+                        <a14:backgroundMark x1="22363" y1="79395" x2="22168" y2="80176"/>
+                        <a14:backgroundMark x1="20801" y1="80859" x2="20801" y2="80859"/>
+                        <a14:backgroundMark x1="21289" y1="81445" x2="21289" y2="81445"/>
+                        <a14:backgroundMark x1="21094" y1="81445" x2="21094" y2="81445"/>
+                        <a14:backgroundMark x1="21387" y1="81543" x2="21387" y2="81543"/>
+                        <a14:backgroundMark x1="21387" y1="81543" x2="21387" y2="81543"/>
+                        <a14:backgroundMark x1="21191" y1="82813" x2="21191" y2="82813"/>
+                        <a14:backgroundMark x1="20996" y1="82520" x2="20996" y2="82520"/>
+                        <a14:backgroundMark x1="20996" y1="82520" x2="20996" y2="82520"/>
+                        <a14:backgroundMark x1="20996" y1="82520" x2="20996" y2="82520"/>
+                        <a14:backgroundMark x1="20996" y1="82227" x2="20996" y2="82227"/>
+                        <a14:backgroundMark x1="21191" y1="82422" x2="21191" y2="82422"/>
+                        <a14:backgroundMark x1="21191" y1="82910" x2="21191" y2="82910"/>
+                        <a14:backgroundMark x1="20898" y1="82910" x2="20898" y2="82910"/>
+                        <a14:backgroundMark x1="39063" y1="85840" x2="39063" y2="85840"/>
+                        <a14:backgroundMark x1="39063" y1="85840" x2="39063" y2="85840"/>
+                        <a14:backgroundMark x1="39160" y1="85352" x2="39160" y2="85352"/>
+                      </a14:backgroundRemoval>
+                    </a14:imgEffect>
+                  </a14:imgLayer>
+                </a14:imgProps>
+              </a:ext>
+              <a:ext uri="{28A0092B-C50C-407E-A947-70E740481C1C}">
+                <a14:useLocalDpi xmlns:a14="http://schemas.microsoft.com/office/drawing/2010/main" val="0"/>
+              </a:ext>
+            </a:extLst>
+          </a:blip>
           <a:stretch>
             <a:fillRect/>
           </a:stretch>
         </p:blipFill>
         <p:spPr>
           <a:xfrm>
-            <a:off x="190139" y="1297097"/>
-            <a:ext cx="2086183" cy="2086183"/>
-          </a:xfrm>
-          <a:prstGeom prst="ellipse">
-            <a:avLst/>
-          </a:prstGeom>
-          <a:ln w="63500" cap="rnd">
-            <a:solidFill>
-              <a:srgbClr val="333333"/>
-            </a:solidFill>
-          </a:ln>
-          <a:effectLst>
-            <a:outerShdw blurRad="381000" dist="292100" dir="5400000" sx="-80000" sy="-18000" rotWithShape="0">
-              <a:srgbClr val="000000">
-                <a:alpha val="22000"/>
-              </a:srgbClr>
-            </a:outerShdw>
-          </a:effectLst>
-          <a:scene3d>
-            <a:camera prst="orthographicFront"/>
-            <a:lightRig rig="contrasting" dir="t">
-              <a:rot lat="0" lon="0" rev="3000000"/>
-            </a:lightRig>
-          </a:scene3d>
-          <a:sp3d contourW="7620">
-            <a:bevelT w="95250" h="31750"/>
-            <a:contourClr>
-              <a:srgbClr val="333333"/>
-            </a:contourClr>
-          </a:sp3d>
+            <a:off x="127818" y="1326216"/>
+            <a:ext cx="2422824" cy="2422824"/>
+          </a:xfrm>
+          <a:prstGeom prst="rect">
+            <a:avLst/>
+          </a:prstGeom>
         </p:spPr>
       </p:pic>
     </p:spTree>
@@ -2395,10 +2508,10 @@
       </p:sp>
       <p:pic>
         <p:nvPicPr>
-          <p:cNvPr id="11" name="Imagen 10">
+          <p:cNvPr id="12" name="Imagen 11">
             <a:extLst>
               <a:ext uri="{FF2B5EF4-FFF2-40B4-BE49-F238E27FC236}">
-                <a16:creationId xmlns:a16="http://schemas.microsoft.com/office/drawing/2014/main" id="{D387B12C-112A-9AC4-FC14-3BF0FDEF20E8}"/>
+                <a16:creationId xmlns:a16="http://schemas.microsoft.com/office/drawing/2014/main" id="{9F7DCC04-2CCA-15BD-0984-432657C7FE08}"/>
               </a:ext>
             </a:extLst>
           </p:cNvPr>
@@ -2408,43 +2521,156 @@
           <p:nvPr/>
         </p:nvPicPr>
         <p:blipFill>
-          <a:blip r:embed="rId3"/>
+          <a:blip r:embed="rId3">
+            <a:extLst>
+              <a:ext uri="{BEBA8EAE-BF5A-486C-A8C5-ECC9F3942E4B}">
+                <a14:imgProps xmlns:a14="http://schemas.microsoft.com/office/drawing/2010/main">
+                  <a14:imgLayer r:embed="rId4">
+                    <a14:imgEffect>
+                      <a14:backgroundRemoval t="6836" b="89844" l="6641" r="91797">
+                        <a14:foregroundMark x1="26172" y1="10059" x2="56348" y2="6934"/>
+                        <a14:foregroundMark x1="56348" y1="6934" x2="66699" y2="8398"/>
+                        <a14:foregroundMark x1="66699" y1="8398" x2="42090" y2="6934"/>
+                        <a14:foregroundMark x1="42090" y1="6934" x2="29492" y2="8691"/>
+                        <a14:foregroundMark x1="29492" y1="8691" x2="38965" y2="7129"/>
+                        <a14:foregroundMark x1="38965" y1="7129" x2="61914" y2="8594"/>
+                        <a14:foregroundMark x1="61914" y1="8594" x2="33301" y2="9961"/>
+                        <a14:foregroundMark x1="33301" y1="9961" x2="45801" y2="9766"/>
+                        <a14:foregroundMark x1="45801" y1="9766" x2="54395" y2="10059"/>
+                        <a14:foregroundMark x1="54395" y1="10059" x2="65723" y2="9766"/>
+                        <a14:foregroundMark x1="65723" y1="9766" x2="40723" y2="9766"/>
+                        <a14:foregroundMark x1="40723" y1="9766" x2="29980" y2="24707"/>
+                        <a14:foregroundMark x1="38281" y1="8301" x2="48730" y2="5859"/>
+                        <a14:foregroundMark x1="48730" y1="5859" x2="59961" y2="7422"/>
+                        <a14:foregroundMark x1="59961" y1="7422" x2="40625" y2="6836"/>
+                        <a14:foregroundMark x1="12598" y1="39355" x2="9863" y2="49512"/>
+                        <a14:foregroundMark x1="9863" y1="49512" x2="19141" y2="48047"/>
+                        <a14:foregroundMark x1="19141" y1="48047" x2="10352" y2="51172"/>
+                        <a14:foregroundMark x1="10352" y1="51172" x2="21777" y2="49414"/>
+                        <a14:foregroundMark x1="21777" y1="49414" x2="22266" y2="48340"/>
+                        <a14:foregroundMark x1="16113" y1="43457" x2="6836" y2="40527"/>
+                        <a14:foregroundMark x1="6836" y1="40527" x2="11523" y2="40039"/>
+                        <a14:foregroundMark x1="8984" y1="40332" x2="9375" y2="39941"/>
+                        <a14:foregroundMark x1="9375" y1="38867" x2="6641" y2="37988"/>
+                        <a14:foregroundMark x1="88965" y1="37793" x2="90723" y2="46387"/>
+                        <a14:foregroundMark x1="90723" y1="46387" x2="83105" y2="50781"/>
+                        <a14:foregroundMark x1="83105" y1="50781" x2="78613" y2="48340"/>
+                        <a14:foregroundMark x1="90039" y1="42383" x2="89746" y2="38672"/>
+                        <a14:foregroundMark x1="89453" y1="40820" x2="91797" y2="39258"/>
+                        <a14:foregroundMark x1="9375" y1="51172" x2="9473" y2="51855"/>
+                        <a14:foregroundMark x1="52832" y1="52930" x2="41211" y2="53809"/>
+                        <a14:foregroundMark x1="41211" y1="53809" x2="39648" y2="65137"/>
+                        <a14:foregroundMark x1="39648" y1="65137" x2="47168" y2="73633"/>
+                        <a14:foregroundMark x1="47168" y1="73633" x2="56641" y2="73730"/>
+                        <a14:foregroundMark x1="56641" y1="73730" x2="58105" y2="63965"/>
+                        <a14:foregroundMark x1="58105" y1="63965" x2="43945" y2="68457"/>
+                        <a14:foregroundMark x1="43945" y1="68457" x2="54883" y2="64844"/>
+                        <a14:foregroundMark x1="54883" y1="64844" x2="45117" y2="70898"/>
+                        <a14:foregroundMark x1="45117" y1="70898" x2="51953" y2="79785"/>
+                        <a14:foregroundMark x1="51953" y1="79785" x2="61230" y2="74414"/>
+                        <a14:foregroundMark x1="61230" y1="74414" x2="52637" y2="78906"/>
+                        <a14:foregroundMark x1="52637" y1="78906" x2="40332" y2="66895"/>
+                        <a14:foregroundMark x1="40332" y1="66895" x2="50488" y2="67969"/>
+                        <a14:foregroundMark x1="50488" y1="67969" x2="45410" y2="75391"/>
+                        <a14:foregroundMark x1="45410" y1="75391" x2="46973" y2="74121"/>
+                        <a14:foregroundMark x1="58203" y1="58691" x2="57031" y2="60059"/>
+                        <a14:foregroundMark x1="60254" y1="59082" x2="58789" y2="59863"/>
+                        <a14:foregroundMark x1="62207" y1="62891" x2="60059" y2="63281"/>
+                        <a14:foregroundMark x1="23291" y1="82617" x2="23730" y2="83496"/>
+                        <a14:foregroundMark x1="23047" y1="82129" x2="23291" y2="82617"/>
+                        <a14:foregroundMark x1="25391" y1="83496" x2="25488" y2="82813"/>
+                        <a14:foregroundMark x1="28418" y1="84006" x2="28418" y2="84570"/>
+                        <a14:foregroundMark x1="33301" y1="84961" x2="32617" y2="84863"/>
+                        <a14:foregroundMark x1="35742" y1="85547" x2="35742" y2="85547"/>
+                        <a14:foregroundMark x1="39258" y1="85156" x2="39258" y2="85156"/>
+                        <a14:foregroundMark x1="43359" y1="85547" x2="43359" y2="85547"/>
+                        <a14:foregroundMark x1="38379" y1="85742" x2="38379" y2="85742"/>
+                        <a14:foregroundMark x1="46973" y1="86035" x2="46973" y2="86035"/>
+                        <a14:foregroundMark x1="51172" y1="86035" x2="51172" y2="86035"/>
+                        <a14:foregroundMark x1="52930" y1="85156" x2="52930" y2="85156"/>
+                        <a14:foregroundMark x1="56543" y1="85156" x2="56543" y2="85156"/>
+                        <a14:foregroundMark x1="61328" y1="83594" x2="61328" y2="83594"/>
+                        <a14:foregroundMark x1="60449" y1="85059" x2="60449" y2="85059"/>
+                        <a14:foregroundMark x1="63184" y1="84375" x2="63184" y2="84375"/>
+                        <a14:foregroundMark x1="67578" y1="84082" x2="67578" y2="84082"/>
+                        <a14:foregroundMark x1="69043" y1="83203" x2="69043" y2="83203"/>
+                        <a14:foregroundMark x1="72070" y1="83008" x2="72070" y2="83008"/>
+                        <a14:foregroundMark x1="75195" y1="82031" x2="75195" y2="82031"/>
+                        <a14:foregroundMark x1="79297" y1="81348" x2="79297" y2="81348"/>
+                        <a14:foregroundMark x1="20020" y1="80664" x2="20020" y2="80664"/>
+                        <a14:foregroundMark x1="19824" y1="81543" x2="19824" y2="81543"/>
+                        <a14:foregroundMark x1="19434" y1="83008" x2="19434" y2="83008"/>
+                        <a14:foregroundMark x1="21289" y1="81543" x2="21359" y2="81264"/>
+                        <a14:foregroundMark x1="21070" y1="82422" x2="21289" y2="81543"/>
+                        <a14:foregroundMark x1="20801" y1="83496" x2="20972" y2="82813"/>
+                        <a14:foregroundMark x1="20898" y1="81152" x2="20898" y2="80664"/>
+                        <a14:foregroundMark x1="79395" y1="81641" x2="79395" y2="81641"/>
+                        <a14:foregroundMark x1="79004" y1="80859" x2="79004" y2="80859"/>
+                        <a14:foregroundMark x1="19434" y1="82520" x2="19434" y2="82520"/>
+                        <a14:foregroundMark x1="22363" y1="83691" x2="22363" y2="83691"/>
+                        <a14:foregroundMark x1="20117" y1="83203" x2="20117" y2="83203"/>
+                        <a14:foregroundMark x1="20117" y1="83008" x2="20117" y2="83008"/>
+                        <a14:foregroundMark x1="19922" y1="82910" x2="19922" y2="82910"/>
+                        <a14:foregroundMark x1="19629" y1="82813" x2="19629" y2="82813"/>
+                        <a14:foregroundMark x1="20020" y1="82813" x2="20020" y2="82813"/>
+                        <a14:foregroundMark x1="19922" y1="82910" x2="19922" y2="82910"/>
+                        <a14:foregroundMark x1="19531" y1="82813" x2="20020" y2="82813"/>
+                        <a14:foregroundMark x1="38770" y1="85645" x2="38770" y2="85645"/>
+                        <a14:foregroundMark x1="38477" y1="86035" x2="38770" y2="85449"/>
+                        <a14:backgroundMark x1="44238" y1="86035" x2="44238" y2="86328"/>
+                        <a14:backgroundMark x1="38965" y1="93945" x2="38965" y2="93945"/>
+                        <a14:backgroundMark x1="28320" y1="83203" x2="28320" y2="83203"/>
+                        <a14:backgroundMark x1="28516" y1="82910" x2="27930" y2="83691"/>
+                        <a14:backgroundMark x1="72559" y1="83203" x2="72559" y2="83203"/>
+                        <a14:backgroundMark x1="76367" y1="82910" x2="76367" y2="82910"/>
+                        <a14:backgroundMark x1="79297" y1="81445" x2="79297" y2="81445"/>
+                        <a14:backgroundMark x1="22266" y1="80176" x2="20605" y2="79492"/>
+                        <a14:backgroundMark x1="20898" y1="81152" x2="20898" y2="81152"/>
+                        <a14:backgroundMark x1="20703" y1="82813" x2="20703" y2="82813"/>
+                        <a14:backgroundMark x1="20313" y1="82422" x2="20313" y2="82422"/>
+                        <a14:backgroundMark x1="21191" y1="82617" x2="21191" y2="82617"/>
+                        <a14:backgroundMark x1="20703" y1="81152" x2="20703" y2="81152"/>
+                        <a14:backgroundMark x1="21191" y1="81152" x2="21484" y2="81348"/>
+                        <a14:backgroundMark x1="21289" y1="82813" x2="21094" y2="82813"/>
+                        <a14:backgroundMark x1="22363" y1="79395" x2="22168" y2="80176"/>
+                        <a14:backgroundMark x1="20801" y1="80859" x2="20801" y2="80859"/>
+                        <a14:backgroundMark x1="21289" y1="81445" x2="21289" y2="81445"/>
+                        <a14:backgroundMark x1="21094" y1="81445" x2="21094" y2="81445"/>
+                        <a14:backgroundMark x1="21387" y1="81543" x2="21387" y2="81543"/>
+                        <a14:backgroundMark x1="21387" y1="81543" x2="21387" y2="81543"/>
+                        <a14:backgroundMark x1="21191" y1="82813" x2="21191" y2="82813"/>
+                        <a14:backgroundMark x1="20996" y1="82520" x2="20996" y2="82520"/>
+                        <a14:backgroundMark x1="20996" y1="82520" x2="20996" y2="82520"/>
+                        <a14:backgroundMark x1="20996" y1="82520" x2="20996" y2="82520"/>
+                        <a14:backgroundMark x1="20996" y1="82227" x2="20996" y2="82227"/>
+                        <a14:backgroundMark x1="21191" y1="82422" x2="21191" y2="82422"/>
+                        <a14:backgroundMark x1="21191" y1="82910" x2="21191" y2="82910"/>
+                        <a14:backgroundMark x1="20898" y1="82910" x2="20898" y2="82910"/>
+                        <a14:backgroundMark x1="39063" y1="85840" x2="39063" y2="85840"/>
+                        <a14:backgroundMark x1="39063" y1="85840" x2="39063" y2="85840"/>
+                        <a14:backgroundMark x1="39160" y1="85352" x2="39160" y2="85352"/>
+                      </a14:backgroundRemoval>
+                    </a14:imgEffect>
+                  </a14:imgLayer>
+                </a14:imgProps>
+              </a:ext>
+              <a:ext uri="{28A0092B-C50C-407E-A947-70E740481C1C}">
+                <a14:useLocalDpi xmlns:a14="http://schemas.microsoft.com/office/drawing/2010/main" val="0"/>
+              </a:ext>
+            </a:extLst>
+          </a:blip>
           <a:stretch>
             <a:fillRect/>
           </a:stretch>
         </p:blipFill>
         <p:spPr>
           <a:xfrm>
-            <a:off x="3754297" y="142124"/>
-            <a:ext cx="1818871" cy="1818871"/>
-          </a:xfrm>
-          <a:prstGeom prst="ellipse">
-            <a:avLst/>
-          </a:prstGeom>
-          <a:ln w="63500" cap="rnd">
-            <a:solidFill>
-              <a:srgbClr val="333333"/>
-            </a:solidFill>
-          </a:ln>
-          <a:effectLst>
-            <a:outerShdw blurRad="381000" dist="292100" dir="5400000" sx="-80000" sy="-18000" rotWithShape="0">
-              <a:srgbClr val="000000">
-                <a:alpha val="22000"/>
-              </a:srgbClr>
-            </a:outerShdw>
-          </a:effectLst>
-          <a:scene3d>
-            <a:camera prst="orthographicFront"/>
-            <a:lightRig rig="contrasting" dir="t">
-              <a:rot lat="0" lon="0" rev="3000000"/>
-            </a:lightRig>
-          </a:scene3d>
-          <a:sp3d contourW="7620">
-            <a:bevelT w="95250" h="31750"/>
-            <a:contourClr>
-              <a:srgbClr val="333333"/>
-            </a:contourClr>
-          </a:sp3d>
+            <a:off x="3444632" y="30030"/>
+            <a:ext cx="2254736" cy="2254736"/>
+          </a:xfrm>
+          <a:prstGeom prst="rect">
+            <a:avLst/>
+          </a:prstGeom>
         </p:spPr>
       </p:pic>
     </p:spTree>
@@ -3319,10 +3545,10 @@
       </p:sp>
       <p:pic>
         <p:nvPicPr>
-          <p:cNvPr id="26" name="Imagen 25">
+          <p:cNvPr id="17" name="Imagen 16">
             <a:extLst>
               <a:ext uri="{FF2B5EF4-FFF2-40B4-BE49-F238E27FC236}">
-                <a16:creationId xmlns:a16="http://schemas.microsoft.com/office/drawing/2014/main" id="{99CF94E9-BDE3-21FC-DBA0-5ABF3328D3EE}"/>
+                <a16:creationId xmlns:a16="http://schemas.microsoft.com/office/drawing/2014/main" id="{0138D9B7-8830-CC2F-3A3B-F7349EE30B3A}"/>
               </a:ext>
             </a:extLst>
           </p:cNvPr>
@@ -3332,15 +3558,129 @@
           <p:nvPr/>
         </p:nvPicPr>
         <p:blipFill>
-          <a:blip r:embed="rId3"/>
+          <a:blip r:embed="rId3">
+            <a:extLst>
+              <a:ext uri="{BEBA8EAE-BF5A-486C-A8C5-ECC9F3942E4B}">
+                <a14:imgProps xmlns:a14="http://schemas.microsoft.com/office/drawing/2010/main">
+                  <a14:imgLayer r:embed="rId4">
+                    <a14:imgEffect>
+                      <a14:backgroundRemoval t="6836" b="89844" l="9570" r="89844">
+                        <a14:foregroundMark x1="26074" y1="9570" x2="57031" y2="6543"/>
+                        <a14:foregroundMark x1="57031" y1="6543" x2="67188" y2="7617"/>
+                        <a14:foregroundMark x1="67188" y1="7617" x2="43066" y2="6836"/>
+                        <a14:foregroundMark x1="43066" y1="6836" x2="34082" y2="8105"/>
+                        <a14:foregroundMark x1="34082" y1="8105" x2="25879" y2="12988"/>
+                        <a14:foregroundMark x1="25879" y1="12988" x2="24707" y2="51367"/>
+                        <a14:foregroundMark x1="24707" y1="51367" x2="42188" y2="71973"/>
+                        <a14:foregroundMark x1="42188" y1="71973" x2="56543" y2="68555"/>
+                        <a14:foregroundMark x1="56543" y1="68555" x2="68359" y2="61914"/>
+                        <a14:foregroundMark x1="68359" y1="61914" x2="75684" y2="50293"/>
+                        <a14:foregroundMark x1="75684" y1="50293" x2="77344" y2="20020"/>
+                        <a14:foregroundMark x1="77344" y1="20020" x2="65430" y2="13574"/>
+                        <a14:foregroundMark x1="65430" y1="13574" x2="33789" y2="9375"/>
+                        <a14:foregroundMark x1="63477" y1="7031" x2="39746" y2="6836"/>
+                        <a14:foregroundMark x1="56250" y1="7031" x2="45313" y2="8105"/>
+                        <a14:foregroundMark x1="45313" y1="8105" x2="75977" y2="13281"/>
+                        <a14:foregroundMark x1="75977" y1="13281" x2="75879" y2="22461"/>
+                        <a14:foregroundMark x1="75879" y1="22461" x2="78809" y2="31543"/>
+                        <a14:foregroundMark x1="78809" y1="31543" x2="76953" y2="31543"/>
+                        <a14:foregroundMark x1="21777" y1="18555" x2="24121" y2="34961"/>
+                        <a14:foregroundMark x1="24121" y1="34961" x2="15039" y2="37402"/>
+                        <a14:foregroundMark x1="15039" y1="37402" x2="10840" y2="40332"/>
+                        <a14:foregroundMark x1="10742" y1="42090" x2="9570" y2="41699"/>
+                        <a14:foregroundMark x1="19238" y1="36816" x2="28809" y2="35156"/>
+                        <a14:foregroundMark x1="20801" y1="41211" x2="20801" y2="41211"/>
+                        <a14:foregroundMark x1="27441" y1="39941" x2="27441" y2="39941"/>
+                        <a14:foregroundMark x1="35938" y1="39063" x2="35938" y2="39063"/>
+                        <a14:foregroundMark x1="29102" y1="39160" x2="29102" y2="39160"/>
+                        <a14:foregroundMark x1="30859" y1="34668" x2="26074" y2="41992"/>
+                        <a14:foregroundMark x1="26074" y1="41992" x2="33398" y2="34082"/>
+                        <a14:foregroundMark x1="33398" y1="34082" x2="33398" y2="34082"/>
+                        <a14:foregroundMark x1="41406" y1="33594" x2="41992" y2="34473"/>
+                        <a14:foregroundMark x1="44922" y1="34180" x2="47559" y2="34570"/>
+                        <a14:foregroundMark x1="44727" y1="15723" x2="43945" y2="16602"/>
+                        <a14:foregroundMark x1="45605" y1="16699" x2="43750" y2="19043"/>
+                        <a14:foregroundMark x1="44629" y1="18457" x2="52930" y2="22363"/>
+                        <a14:foregroundMark x1="52930" y1="22363" x2="53320" y2="20215"/>
+                        <a14:foregroundMark x1="58301" y1="19531" x2="57617" y2="19922"/>
+                        <a14:foregroundMark x1="43750" y1="21875" x2="42188" y2="20117"/>
+                        <a14:foregroundMark x1="40820" y1="25293" x2="57520" y2="22949"/>
+                        <a14:foregroundMark x1="57520" y1="22949" x2="39258" y2="26660"/>
+                        <a14:foregroundMark x1="53418" y1="27051" x2="50781" y2="27441"/>
+                        <a14:foregroundMark x1="47559" y1="27637" x2="49512" y2="28906"/>
+                        <a14:foregroundMark x1="41797" y1="34961" x2="41211" y2="42285"/>
+                        <a14:foregroundMark x1="41797" y1="41504" x2="37207" y2="43848"/>
+                        <a14:foregroundMark x1="44629" y1="41016" x2="51172" y2="35254"/>
+                        <a14:foregroundMark x1="51172" y1="35254" x2="48242" y2="39258"/>
+                        <a14:foregroundMark x1="40625" y1="34863" x2="37793" y2="32813"/>
+                        <a14:foregroundMark x1="44531" y1="71875" x2="37988" y2="65918"/>
+                        <a14:foregroundMark x1="37988" y1="65918" x2="40332" y2="56738"/>
+                        <a14:foregroundMark x1="40332" y1="56738" x2="51172" y2="51953"/>
+                        <a14:foregroundMark x1="51172" y1="51953" x2="59375" y2="54980"/>
+                        <a14:foregroundMark x1="59375" y1="54980" x2="61426" y2="64160"/>
+                        <a14:foregroundMark x1="61426" y1="64160" x2="43555" y2="72070"/>
+                        <a14:foregroundMark x1="54004" y1="65137" x2="42969" y2="62305"/>
+                        <a14:foregroundMark x1="42969" y1="62305" x2="49512" y2="56445"/>
+                        <a14:foregroundMark x1="49512" y1="56445" x2="58203" y2="62109"/>
+                        <a14:foregroundMark x1="58203" y1="62109" x2="45703" y2="61230"/>
+                        <a14:foregroundMark x1="45703" y1="61230" x2="43164" y2="62012"/>
+                        <a14:foregroundMark x1="55273" y1="47656" x2="53223" y2="47949"/>
+                        <a14:foregroundMark x1="20020" y1="80859" x2="20020" y2="80859"/>
+                        <a14:foregroundMark x1="23438" y1="82227" x2="23438" y2="82227"/>
+                        <a14:foregroundMark x1="25391" y1="82910" x2="25391" y2="82910"/>
+                        <a14:foregroundMark x1="28906" y1="83398" x2="28906" y2="83398"/>
+                        <a14:foregroundMark x1="32617" y1="83789" x2="32617" y2="83789"/>
+                        <a14:foregroundMark x1="30859" y1="84375" x2="30859" y2="84375"/>
+                        <a14:foregroundMark x1="35645" y1="84863" x2="35645" y2="84863"/>
+                        <a14:foregroundMark x1="38379" y1="86328" x2="38379" y2="86328"/>
+                        <a14:foregroundMark x1="43066" y1="86426" x2="43066" y2="86426"/>
+                        <a14:foregroundMark x1="46973" y1="86133" x2="46973" y2="86133"/>
+                        <a14:foregroundMark x1="78613" y1="81445" x2="78613" y2="81445"/>
+                        <a14:foregroundMark x1="77539" y1="82227" x2="77539" y2="82227"/>
+                        <a14:foregroundMark x1="73145" y1="83594" x2="73145" y2="83594"/>
+                        <a14:foregroundMark x1="69629" y1="84375" x2="69629" y2="84375"/>
+                        <a14:foregroundMark x1="67090" y1="84863" x2="67090" y2="84863"/>
+                        <a14:foregroundMark x1="65820" y1="85156" x2="65820" y2="85156"/>
+                        <a14:foregroundMark x1="61523" y1="84375" x2="61523" y2="84375"/>
+                        <a14:foregroundMark x1="63672" y1="84375" x2="63672" y2="84375"/>
+                        <a14:foregroundMark x1="59082" y1="86426" x2="59082" y2="86426"/>
+                        <a14:foregroundMark x1="55273" y1="86523" x2="55273" y2="86523"/>
+                        <a14:foregroundMark x1="51465" y1="86133" x2="51465" y2="86133"/>
+                        <a14:foregroundMark x1="57129" y1="85352" x2="57129" y2="85352"/>
+                        <a14:foregroundMark x1="61328" y1="83398" x2="61328" y2="83398"/>
+                        <a14:foregroundMark x1="61426" y1="83496" x2="61426" y2="83496"/>
+                        <a14:foregroundMark x1="61133" y1="83496" x2="61328" y2="83398"/>
+                        <a14:foregroundMark x1="54102" y1="86035" x2="54102" y2="86035"/>
+                        <a14:foregroundMark x1="53516" y1="85156" x2="53516" y2="85156"/>
+                        <a14:foregroundMark x1="60449" y1="84375" x2="60449" y2="84375"/>
+                        <a14:backgroundMark x1="44531" y1="86328" x2="44531" y2="86328"/>
+                        <a14:backgroundMark x1="39258" y1="86035" x2="39258" y2="86035"/>
+                        <a14:backgroundMark x1="76367" y1="82715" x2="76367" y2="82715"/>
+                        <a14:backgroundMark x1="72461" y1="82910" x2="72461" y2="82910"/>
+                        <a14:backgroundMark x1="61035" y1="83203" x2="61133" y2="83203"/>
+                        <a14:backgroundMark x1="61719" y1="83594" x2="61719" y2="83594"/>
+                        <a14:backgroundMark x1="61035" y1="83105" x2="61035" y2="83105"/>
+                        <a14:backgroundMark x1="61230" y1="83301" x2="61230" y2="83301"/>
+                        <a14:backgroundMark x1="61035" y1="83301" x2="61035" y2="83301"/>
+                        <a14:backgroundMark x1="53516" y1="86230" x2="53516" y2="86230"/>
+                      </a14:backgroundRemoval>
+                    </a14:imgEffect>
+                  </a14:imgLayer>
+                </a14:imgProps>
+              </a:ext>
+              <a:ext uri="{28A0092B-C50C-407E-A947-70E740481C1C}">
+                <a14:useLocalDpi xmlns:a14="http://schemas.microsoft.com/office/drawing/2010/main" val="0"/>
+              </a:ext>
+            </a:extLst>
+          </a:blip>
           <a:stretch>
             <a:fillRect/>
           </a:stretch>
         </p:blipFill>
         <p:spPr>
           <a:xfrm>
-            <a:off x="6263640" y="576072"/>
-            <a:ext cx="3200400" cy="3200400"/>
+            <a:off x="6619603" y="1246851"/>
+            <a:ext cx="2488474" cy="2488474"/>
           </a:xfrm>
           <a:prstGeom prst="rect">
             <a:avLst/>
@@ -4175,10 +4515,10 @@
       </p:sp>
       <p:pic>
         <p:nvPicPr>
-          <p:cNvPr id="23" name="Imagen 22">
+          <p:cNvPr id="25" name="Imagen 24">
             <a:extLst>
               <a:ext uri="{FF2B5EF4-FFF2-40B4-BE49-F238E27FC236}">
-                <a16:creationId xmlns:a16="http://schemas.microsoft.com/office/drawing/2014/main" id="{58B11AFB-B2AA-E656-3422-F81A562007AC}"/>
+                <a16:creationId xmlns:a16="http://schemas.microsoft.com/office/drawing/2014/main" id="{538F13FB-B492-B64A-18EE-BC0B0BACB4B8}"/>
               </a:ext>
             </a:extLst>
           </p:cNvPr>
@@ -4188,15 +4528,152 @@
           <p:nvPr/>
         </p:nvPicPr>
         <p:blipFill>
-          <a:blip r:embed="rId3"/>
+          <a:blip r:embed="rId3">
+            <a:extLst>
+              <a:ext uri="{BEBA8EAE-BF5A-486C-A8C5-ECC9F3942E4B}">
+                <a14:imgProps xmlns:a14="http://schemas.microsoft.com/office/drawing/2010/main">
+                  <a14:imgLayer r:embed="rId4">
+                    <a14:imgEffect>
+                      <a14:backgroundRemoval t="6836" b="89844" l="6641" r="91797">
+                        <a14:foregroundMark x1="26172" y1="10059" x2="56348" y2="6934"/>
+                        <a14:foregroundMark x1="56348" y1="6934" x2="66699" y2="8398"/>
+                        <a14:foregroundMark x1="66699" y1="8398" x2="42090" y2="6934"/>
+                        <a14:foregroundMark x1="42090" y1="6934" x2="29492" y2="8691"/>
+                        <a14:foregroundMark x1="29492" y1="8691" x2="38965" y2="7129"/>
+                        <a14:foregroundMark x1="38965" y1="7129" x2="61914" y2="8594"/>
+                        <a14:foregroundMark x1="61914" y1="8594" x2="33301" y2="9961"/>
+                        <a14:foregroundMark x1="33301" y1="9961" x2="45801" y2="9766"/>
+                        <a14:foregroundMark x1="45801" y1="9766" x2="54395" y2="10059"/>
+                        <a14:foregroundMark x1="54395" y1="10059" x2="65723" y2="9766"/>
+                        <a14:foregroundMark x1="65723" y1="9766" x2="40723" y2="9766"/>
+                        <a14:foregroundMark x1="40723" y1="9766" x2="29980" y2="24707"/>
+                        <a14:foregroundMark x1="38281" y1="8301" x2="48730" y2="5859"/>
+                        <a14:foregroundMark x1="48730" y1="5859" x2="59961" y2="7422"/>
+                        <a14:foregroundMark x1="59961" y1="7422" x2="40625" y2="6836"/>
+                        <a14:foregroundMark x1="12598" y1="39355" x2="9863" y2="49512"/>
+                        <a14:foregroundMark x1="9863" y1="49512" x2="19141" y2="48047"/>
+                        <a14:foregroundMark x1="19141" y1="48047" x2="10352" y2="51172"/>
+                        <a14:foregroundMark x1="10352" y1="51172" x2="21777" y2="49414"/>
+                        <a14:foregroundMark x1="21777" y1="49414" x2="22266" y2="48340"/>
+                        <a14:foregroundMark x1="16113" y1="43457" x2="6836" y2="40527"/>
+                        <a14:foregroundMark x1="6836" y1="40527" x2="11523" y2="40039"/>
+                        <a14:foregroundMark x1="8984" y1="40332" x2="9375" y2="39941"/>
+                        <a14:foregroundMark x1="9375" y1="38867" x2="6641" y2="37988"/>
+                        <a14:foregroundMark x1="88965" y1="37793" x2="90723" y2="46387"/>
+                        <a14:foregroundMark x1="90723" y1="46387" x2="83105" y2="50781"/>
+                        <a14:foregroundMark x1="83105" y1="50781" x2="78613" y2="48340"/>
+                        <a14:foregroundMark x1="90039" y1="42383" x2="89746" y2="38672"/>
+                        <a14:foregroundMark x1="89453" y1="40820" x2="91797" y2="39258"/>
+                        <a14:foregroundMark x1="9375" y1="51172" x2="9473" y2="51855"/>
+                        <a14:foregroundMark x1="52832" y1="52930" x2="41211" y2="53809"/>
+                        <a14:foregroundMark x1="41211" y1="53809" x2="39648" y2="65137"/>
+                        <a14:foregroundMark x1="39648" y1="65137" x2="47168" y2="73633"/>
+                        <a14:foregroundMark x1="47168" y1="73633" x2="56641" y2="73730"/>
+                        <a14:foregroundMark x1="56641" y1="73730" x2="58105" y2="63965"/>
+                        <a14:foregroundMark x1="58105" y1="63965" x2="43945" y2="68457"/>
+                        <a14:foregroundMark x1="43945" y1="68457" x2="54883" y2="64844"/>
+                        <a14:foregroundMark x1="54883" y1="64844" x2="45117" y2="70898"/>
+                        <a14:foregroundMark x1="45117" y1="70898" x2="51953" y2="79785"/>
+                        <a14:foregroundMark x1="51953" y1="79785" x2="61230" y2="74414"/>
+                        <a14:foregroundMark x1="61230" y1="74414" x2="52637" y2="78906"/>
+                        <a14:foregroundMark x1="52637" y1="78906" x2="40332" y2="66895"/>
+                        <a14:foregroundMark x1="40332" y1="66895" x2="50488" y2="67969"/>
+                        <a14:foregroundMark x1="50488" y1="67969" x2="45410" y2="75391"/>
+                        <a14:foregroundMark x1="45410" y1="75391" x2="46973" y2="74121"/>
+                        <a14:foregroundMark x1="58203" y1="58691" x2="57031" y2="60059"/>
+                        <a14:foregroundMark x1="60254" y1="59082" x2="58789" y2="59863"/>
+                        <a14:foregroundMark x1="62207" y1="62891" x2="60059" y2="63281"/>
+                        <a14:foregroundMark x1="23291" y1="82617" x2="23730" y2="83496"/>
+                        <a14:foregroundMark x1="23047" y1="82129" x2="23291" y2="82617"/>
+                        <a14:foregroundMark x1="25391" y1="83496" x2="25488" y2="82813"/>
+                        <a14:foregroundMark x1="28418" y1="84006" x2="28418" y2="84570"/>
+                        <a14:foregroundMark x1="33301" y1="84961" x2="32617" y2="84863"/>
+                        <a14:foregroundMark x1="35742" y1="85547" x2="35742" y2="85547"/>
+                        <a14:foregroundMark x1="39258" y1="85156" x2="39258" y2="85156"/>
+                        <a14:foregroundMark x1="43359" y1="85547" x2="43359" y2="85547"/>
+                        <a14:foregroundMark x1="38379" y1="85742" x2="38379" y2="85742"/>
+                        <a14:foregroundMark x1="46973" y1="86035" x2="46973" y2="86035"/>
+                        <a14:foregroundMark x1="51172" y1="86035" x2="51172" y2="86035"/>
+                        <a14:foregroundMark x1="52930" y1="85156" x2="52930" y2="85156"/>
+                        <a14:foregroundMark x1="56543" y1="85156" x2="56543" y2="85156"/>
+                        <a14:foregroundMark x1="61328" y1="83594" x2="61328" y2="83594"/>
+                        <a14:foregroundMark x1="60449" y1="85059" x2="60449" y2="85059"/>
+                        <a14:foregroundMark x1="63184" y1="84375" x2="63184" y2="84375"/>
+                        <a14:foregroundMark x1="67578" y1="84082" x2="67578" y2="84082"/>
+                        <a14:foregroundMark x1="69043" y1="83203" x2="69043" y2="83203"/>
+                        <a14:foregroundMark x1="72070" y1="83008" x2="72070" y2="83008"/>
+                        <a14:foregroundMark x1="75195" y1="82031" x2="75195" y2="82031"/>
+                        <a14:foregroundMark x1="79297" y1="81348" x2="79297" y2="81348"/>
+                        <a14:foregroundMark x1="20020" y1="80664" x2="20020" y2="80664"/>
+                        <a14:foregroundMark x1="19824" y1="81543" x2="19824" y2="81543"/>
+                        <a14:foregroundMark x1="19434" y1="83008" x2="19434" y2="83008"/>
+                        <a14:foregroundMark x1="21289" y1="81543" x2="21359" y2="81264"/>
+                        <a14:foregroundMark x1="21070" y1="82422" x2="21289" y2="81543"/>
+                        <a14:foregroundMark x1="20801" y1="83496" x2="20972" y2="82813"/>
+                        <a14:foregroundMark x1="20898" y1="81152" x2="20898" y2="80664"/>
+                        <a14:foregroundMark x1="79395" y1="81641" x2="79395" y2="81641"/>
+                        <a14:foregroundMark x1="79004" y1="80859" x2="79004" y2="80859"/>
+                        <a14:foregroundMark x1="19434" y1="82520" x2="19434" y2="82520"/>
+                        <a14:foregroundMark x1="22363" y1="83691" x2="22363" y2="83691"/>
+                        <a14:foregroundMark x1="20117" y1="83203" x2="20117" y2="83203"/>
+                        <a14:foregroundMark x1="20117" y1="83008" x2="20117" y2="83008"/>
+                        <a14:foregroundMark x1="19922" y1="82910" x2="19922" y2="82910"/>
+                        <a14:foregroundMark x1="19629" y1="82813" x2="19629" y2="82813"/>
+                        <a14:foregroundMark x1="20020" y1="82813" x2="20020" y2="82813"/>
+                        <a14:foregroundMark x1="19922" y1="82910" x2="19922" y2="82910"/>
+                        <a14:foregroundMark x1="19531" y1="82813" x2="20020" y2="82813"/>
+                        <a14:foregroundMark x1="38770" y1="85645" x2="38770" y2="85645"/>
+                        <a14:foregroundMark x1="38477" y1="86035" x2="38770" y2="85449"/>
+                        <a14:backgroundMark x1="44238" y1="86035" x2="44238" y2="86328"/>
+                        <a14:backgroundMark x1="38965" y1="93945" x2="38965" y2="93945"/>
+                        <a14:backgroundMark x1="28320" y1="83203" x2="28320" y2="83203"/>
+                        <a14:backgroundMark x1="28516" y1="82910" x2="27930" y2="83691"/>
+                        <a14:backgroundMark x1="72559" y1="83203" x2="72559" y2="83203"/>
+                        <a14:backgroundMark x1="76367" y1="82910" x2="76367" y2="82910"/>
+                        <a14:backgroundMark x1="79297" y1="81445" x2="79297" y2="81445"/>
+                        <a14:backgroundMark x1="22266" y1="80176" x2="20605" y2="79492"/>
+                        <a14:backgroundMark x1="20898" y1="81152" x2="20898" y2="81152"/>
+                        <a14:backgroundMark x1="20703" y1="82813" x2="20703" y2="82813"/>
+                        <a14:backgroundMark x1="20313" y1="82422" x2="20313" y2="82422"/>
+                        <a14:backgroundMark x1="21191" y1="82617" x2="21191" y2="82617"/>
+                        <a14:backgroundMark x1="20703" y1="81152" x2="20703" y2="81152"/>
+                        <a14:backgroundMark x1="21191" y1="81152" x2="21484" y2="81348"/>
+                        <a14:backgroundMark x1="21289" y1="82813" x2="21094" y2="82813"/>
+                        <a14:backgroundMark x1="22363" y1="79395" x2="22168" y2="80176"/>
+                        <a14:backgroundMark x1="20801" y1="80859" x2="20801" y2="80859"/>
+                        <a14:backgroundMark x1="21289" y1="81445" x2="21289" y2="81445"/>
+                        <a14:backgroundMark x1="21094" y1="81445" x2="21094" y2="81445"/>
+                        <a14:backgroundMark x1="21387" y1="81543" x2="21387" y2="81543"/>
+                        <a14:backgroundMark x1="21387" y1="81543" x2="21387" y2="81543"/>
+                        <a14:backgroundMark x1="21191" y1="82813" x2="21191" y2="82813"/>
+                        <a14:backgroundMark x1="20996" y1="82520" x2="20996" y2="82520"/>
+                        <a14:backgroundMark x1="20996" y1="82520" x2="20996" y2="82520"/>
+                        <a14:backgroundMark x1="20996" y1="82520" x2="20996" y2="82520"/>
+                        <a14:backgroundMark x1="20996" y1="82227" x2="20996" y2="82227"/>
+                        <a14:backgroundMark x1="21191" y1="82422" x2="21191" y2="82422"/>
+                        <a14:backgroundMark x1="21191" y1="82910" x2="21191" y2="82910"/>
+                        <a14:backgroundMark x1="20898" y1="82910" x2="20898" y2="82910"/>
+                        <a14:backgroundMark x1="39063" y1="85840" x2="39063" y2="85840"/>
+                        <a14:backgroundMark x1="39063" y1="85840" x2="39063" y2="85840"/>
+                        <a14:backgroundMark x1="39160" y1="85352" x2="39160" y2="85352"/>
+                      </a14:backgroundRemoval>
+                    </a14:imgEffect>
+                  </a14:imgLayer>
+                </a14:imgProps>
+              </a:ext>
+              <a:ext uri="{28A0092B-C50C-407E-A947-70E740481C1C}">
+                <a14:useLocalDpi xmlns:a14="http://schemas.microsoft.com/office/drawing/2010/main" val="0"/>
+              </a:ext>
+            </a:extLst>
+          </a:blip>
           <a:stretch>
             <a:fillRect/>
           </a:stretch>
         </p:blipFill>
         <p:spPr>
           <a:xfrm>
-            <a:off x="1751239" y="1591056"/>
-            <a:ext cx="1343841" cy="1343841"/>
+            <a:off x="1734094" y="1472184"/>
+            <a:ext cx="1469572" cy="1469572"/>
           </a:xfrm>
           <a:prstGeom prst="rect">
             <a:avLst/>

</xml_diff>